<commit_message>
Clarify slide 3 method wording in GEMEPH presentation
Co-authored-by: Claudio Larrea <claudiomlarrea@users.noreply.github.com>
</commit_message>
<xml_diff>
--- a/JORNADAS IA 2026/Presentacion_FINAL.pptx
+++ b/JORNADAS IA 2026/Presentacion_FINAL.pptx
@@ -4680,44 +4680,7 @@
               </a:spcAft>
             </a:pPr>
             <a:r>
-              <a:rPr dirty="0">
-                <a:solidFill>
-                  <a:schemeClr val="tx1"/>
-                </a:solidFill>
-              </a:rPr>
-              <a:t>¿</a:t>
-            </a:r>
-            <a:r>
-              <a:rPr dirty="0" err="1">
-                <a:solidFill>
-                  <a:schemeClr val="tx1"/>
-                </a:solidFill>
-              </a:rPr>
-              <a:t>Cómo</a:t>
-            </a:r>
-            <a:r>
-              <a:rPr dirty="0">
-                <a:solidFill>
-                  <a:schemeClr val="tx1"/>
-                </a:solidFill>
-              </a:rPr>
-              <a:t> </a:t>
-            </a:r>
-            <a:r>
-              <a:rPr dirty="0" err="1">
-                <a:solidFill>
-                  <a:schemeClr val="tx1"/>
-                </a:solidFill>
-              </a:rPr>
-              <a:t>funciona</a:t>
-            </a:r>
-            <a:r>
-              <a:rPr dirty="0">
-                <a:solidFill>
-                  <a:schemeClr val="tx1"/>
-                </a:solidFill>
-              </a:rPr>
-              <a:t> GEMEPH?</a:t>
+              <a:t>¿Cómo funciona GEMEPH?</a:t>
             </a:r>
           </a:p>
           <a:p>
@@ -4727,124 +4690,7 @@
               </a:spcAft>
             </a:pPr>
             <a:r>
-              <a:rPr dirty="0">
-                <a:solidFill>
-                  <a:schemeClr val="tx1"/>
-                </a:solidFill>
-              </a:rPr>
-              <a:t>• </a:t>
-            </a:r>
-            <a:r>
-              <a:rPr dirty="0" err="1">
-                <a:solidFill>
-                  <a:schemeClr val="tx1"/>
-                </a:solidFill>
-              </a:rPr>
-              <a:t>Integración</a:t>
-            </a:r>
-            <a:r>
-              <a:rPr dirty="0">
-                <a:solidFill>
-                  <a:schemeClr val="tx1"/>
-                </a:solidFill>
-              </a:rPr>
-              <a:t> de </a:t>
-            </a:r>
-            <a:r>
-              <a:rPr dirty="0" err="1">
-                <a:solidFill>
-                  <a:schemeClr val="tx1"/>
-                </a:solidFill>
-              </a:rPr>
-              <a:t>microdatos</a:t>
-            </a:r>
-            <a:r>
-              <a:rPr dirty="0">
-                <a:solidFill>
-                  <a:schemeClr val="tx1"/>
-                </a:solidFill>
-              </a:rPr>
-              <a:t> EPH 2022–2024 (4.º </a:t>
-            </a:r>
-            <a:r>
-              <a:rPr dirty="0" err="1">
-                <a:solidFill>
-                  <a:schemeClr val="tx1"/>
-                </a:solidFill>
-              </a:rPr>
-              <a:t>trimestre</a:t>
-            </a:r>
-            <a:r>
-              <a:rPr dirty="0">
-                <a:solidFill>
-                  <a:schemeClr val="tx1"/>
-                </a:solidFill>
-              </a:rPr>
-              <a:t>, </a:t>
-            </a:r>
-            <a:r>
-              <a:rPr dirty="0" err="1">
-                <a:solidFill>
-                  <a:schemeClr val="tx1"/>
-                </a:solidFill>
-              </a:rPr>
-              <a:t>módulo</a:t>
-            </a:r>
-            <a:r>
-              <a:rPr dirty="0">
-                <a:solidFill>
-                  <a:schemeClr val="tx1"/>
-                </a:solidFill>
-              </a:rPr>
-              <a:t> TIC): 114.280 </a:t>
-            </a:r>
-            <a:r>
-              <a:rPr dirty="0" err="1">
-                <a:solidFill>
-                  <a:schemeClr val="tx1"/>
-                </a:solidFill>
-              </a:rPr>
-              <a:t>registros</a:t>
-            </a:r>
-            <a:r>
-              <a:rPr dirty="0">
-                <a:solidFill>
-                  <a:schemeClr val="tx1"/>
-                </a:solidFill>
-              </a:rPr>
-              <a:t> </a:t>
-            </a:r>
-            <a:r>
-              <a:rPr dirty="0" err="1">
-                <a:solidFill>
-                  <a:schemeClr val="tx1"/>
-                </a:solidFill>
-              </a:rPr>
-              <a:t>individuales</a:t>
-            </a:r>
-            <a:r>
-              <a:rPr dirty="0">
-                <a:solidFill>
-                  <a:schemeClr val="tx1"/>
-                </a:solidFill>
-              </a:rPr>
-              <a:t>, </a:t>
-            </a:r>
-            <a:r>
-              <a:rPr dirty="0" err="1">
-                <a:solidFill>
-                  <a:schemeClr val="tx1"/>
-                </a:solidFill>
-              </a:rPr>
-              <a:t>ponderados</a:t>
-            </a:r>
-            <a:r>
-              <a:rPr dirty="0">
-                <a:solidFill>
-                  <a:schemeClr val="tx1"/>
-                </a:solidFill>
-              </a:rPr>
-              <a:t> con PONDERA.</a:t>
+              <a:t>• Parte de microdatos oficiales de la EPH (2022–2024, 4.º trimestre, módulo TIC): 114.280 personas, con el peso estadístico del INDEC.</a:t>
             </a:r>
           </a:p>
           <a:p>
@@ -4854,140 +4700,7 @@
               </a:spcAft>
             </a:pPr>
             <a:r>
-              <a:rPr dirty="0">
-                <a:solidFill>
-                  <a:schemeClr val="tx1"/>
-                </a:solidFill>
-              </a:rPr>
-              <a:t>• </a:t>
-            </a:r>
-            <a:r>
-              <a:rPr dirty="0" err="1">
-                <a:solidFill>
-                  <a:schemeClr val="tx1"/>
-                </a:solidFill>
-              </a:rPr>
-              <a:t>Cálculo</a:t>
-            </a:r>
-            <a:r>
-              <a:rPr dirty="0">
-                <a:solidFill>
-                  <a:schemeClr val="tx1"/>
-                </a:solidFill>
-              </a:rPr>
-              <a:t> de </a:t>
-            </a:r>
-            <a:r>
-              <a:rPr dirty="0" err="1">
-                <a:solidFill>
-                  <a:schemeClr val="tx1"/>
-                </a:solidFill>
-              </a:rPr>
-              <a:t>indicadores</a:t>
-            </a:r>
-            <a:r>
-              <a:rPr dirty="0">
-                <a:solidFill>
-                  <a:schemeClr val="tx1"/>
-                </a:solidFill>
-              </a:rPr>
-              <a:t>: </a:t>
-            </a:r>
-            <a:r>
-              <a:rPr dirty="0" err="1">
-                <a:solidFill>
-                  <a:schemeClr val="tx1"/>
-                </a:solidFill>
-              </a:rPr>
-              <a:t>exclusión</a:t>
-            </a:r>
-            <a:r>
-              <a:rPr dirty="0">
-                <a:solidFill>
-                  <a:schemeClr val="tx1"/>
-                </a:solidFill>
-              </a:rPr>
-              <a:t> digital, </a:t>
-            </a:r>
-            <a:r>
-              <a:rPr dirty="0" err="1">
-                <a:solidFill>
-                  <a:schemeClr val="tx1"/>
-                </a:solidFill>
-              </a:rPr>
-              <a:t>vulnerabilidad</a:t>
-            </a:r>
-            <a:r>
-              <a:rPr dirty="0">
-                <a:solidFill>
-                  <a:schemeClr val="tx1"/>
-                </a:solidFill>
-              </a:rPr>
-              <a:t> social, </a:t>
-            </a:r>
-            <a:r>
-              <a:rPr dirty="0" err="1">
-                <a:solidFill>
-                  <a:schemeClr val="tx1"/>
-                </a:solidFill>
-              </a:rPr>
-              <a:t>movilidad</a:t>
-            </a:r>
-            <a:r>
-              <a:rPr dirty="0">
-                <a:solidFill>
-                  <a:schemeClr val="tx1"/>
-                </a:solidFill>
-              </a:rPr>
-              <a:t> proxy, </a:t>
-            </a:r>
-            <a:r>
-              <a:rPr dirty="0" err="1">
-                <a:solidFill>
-                  <a:schemeClr val="tx1"/>
-                </a:solidFill>
-              </a:rPr>
-              <a:t>ocupación</a:t>
-            </a:r>
-            <a:r>
-              <a:rPr dirty="0">
-                <a:solidFill>
-                  <a:schemeClr val="tx1"/>
-                </a:solidFill>
-              </a:rPr>
-              <a:t>, </a:t>
-            </a:r>
-            <a:r>
-              <a:rPr dirty="0" err="1">
-                <a:solidFill>
-                  <a:schemeClr val="tx1"/>
-                </a:solidFill>
-              </a:rPr>
-              <a:t>educación</a:t>
-            </a:r>
-            <a:r>
-              <a:rPr dirty="0">
-                <a:solidFill>
-                  <a:schemeClr val="tx1"/>
-                </a:solidFill>
-              </a:rPr>
-              <a:t> e </a:t>
-            </a:r>
-            <a:r>
-              <a:rPr dirty="0" err="1">
-                <a:solidFill>
-                  <a:schemeClr val="tx1"/>
-                </a:solidFill>
-              </a:rPr>
-              <a:t>informalidad</a:t>
-            </a:r>
-            <a:r>
-              <a:rPr dirty="0">
-                <a:solidFill>
-                  <a:schemeClr val="tx1"/>
-                </a:solidFill>
-              </a:rPr>
-              <a:t>.</a:t>
+              <a:t>• Calcula indicadores fáciles de interpretar: exclusión digital, vulnerabilidad, movilidad social, empleo, educación e informalidad.</a:t>
             </a:r>
           </a:p>
           <a:p>
@@ -4997,100 +4710,7 @@
               </a:spcAft>
             </a:pPr>
             <a:r>
-              <a:rPr dirty="0">
-                <a:solidFill>
-                  <a:schemeClr val="tx1"/>
-                </a:solidFill>
-              </a:rPr>
-              <a:t>• </a:t>
-            </a:r>
-            <a:r>
-              <a:rPr dirty="0" err="1">
-                <a:solidFill>
-                  <a:schemeClr val="tx1"/>
-                </a:solidFill>
-              </a:rPr>
-              <a:t>Modelado</a:t>
-            </a:r>
-            <a:r>
-              <a:rPr dirty="0">
-                <a:solidFill>
-                  <a:schemeClr val="tx1"/>
-                </a:solidFill>
-              </a:rPr>
-              <a:t> </a:t>
-            </a:r>
-            <a:r>
-              <a:rPr dirty="0" err="1">
-                <a:solidFill>
-                  <a:schemeClr val="tx1"/>
-                </a:solidFill>
-              </a:rPr>
-              <a:t>en</a:t>
-            </a:r>
-            <a:r>
-              <a:rPr dirty="0">
-                <a:solidFill>
-                  <a:schemeClr val="tx1"/>
-                </a:solidFill>
-              </a:rPr>
-              <a:t> Python (pandas, scikit-learn): </a:t>
-            </a:r>
-            <a:r>
-              <a:rPr dirty="0" err="1">
-                <a:solidFill>
-                  <a:schemeClr val="tx1"/>
-                </a:solidFill>
-              </a:rPr>
-              <a:t>perfiles</a:t>
-            </a:r>
-            <a:r>
-              <a:rPr dirty="0">
-                <a:solidFill>
-                  <a:schemeClr val="tx1"/>
-                </a:solidFill>
-              </a:rPr>
-              <a:t> k-means y </a:t>
-            </a:r>
-            <a:r>
-              <a:rPr dirty="0" err="1">
-                <a:solidFill>
-                  <a:schemeClr val="tx1"/>
-                </a:solidFill>
-              </a:rPr>
-              <a:t>predicción</a:t>
-            </a:r>
-            <a:r>
-              <a:rPr dirty="0">
-                <a:solidFill>
-                  <a:schemeClr val="tx1"/>
-                </a:solidFill>
-              </a:rPr>
-              <a:t> de </a:t>
-            </a:r>
-            <a:r>
-              <a:rPr dirty="0" err="1">
-                <a:solidFill>
-                  <a:schemeClr val="tx1"/>
-                </a:solidFill>
-              </a:rPr>
-              <a:t>exclusión</a:t>
-            </a:r>
-            <a:r>
-              <a:rPr dirty="0">
-                <a:solidFill>
-                  <a:schemeClr val="tx1"/>
-                </a:solidFill>
-              </a:rPr>
-              <a:t> digital </a:t>
-            </a:r>
-            <a:r>
-              <a:rPr dirty="0" err="1">
-                <a:solidFill>
-                  <a:schemeClr val="tx1"/>
-                </a:solidFill>
-              </a:rPr>
-              <a:t>alta.</a:t>
+              <a:t>• Usa inteligencia artificial para agrupar perfiles y estimar quiénes tienen mayor riesgo de exclusión digital alta.</a:t>
             </a:r>
             <a:endParaRPr dirty="0">
               <a:solidFill>
@@ -5100,336 +4720,17 @@
           </a:p>
           <a:p>
             <a:r>
-              <a:rPr dirty="0">
-                <a:solidFill>
-                  <a:schemeClr val="tx1"/>
-                </a:solidFill>
-              </a:rPr>
-              <a:t>• </a:t>
-            </a:r>
-            <a:r>
-              <a:rPr dirty="0" err="1">
-                <a:solidFill>
-                  <a:schemeClr val="tx1"/>
-                </a:solidFill>
-              </a:rPr>
-              <a:t>Simulación</a:t>
-            </a:r>
-            <a:r>
-              <a:rPr dirty="0">
-                <a:solidFill>
-                  <a:schemeClr val="tx1"/>
-                </a:solidFill>
-              </a:rPr>
-              <a:t> </a:t>
-            </a:r>
-            <a:r>
-              <a:rPr dirty="0" err="1">
-                <a:solidFill>
-                  <a:schemeClr val="tx1"/>
-                </a:solidFill>
-              </a:rPr>
-              <a:t>mediante</a:t>
-            </a:r>
-            <a:r>
-              <a:rPr dirty="0">
-                <a:solidFill>
-                  <a:schemeClr val="tx1"/>
-                </a:solidFill>
-              </a:rPr>
-              <a:t> </a:t>
-            </a:r>
-            <a:r>
-              <a:rPr dirty="0" err="1">
-                <a:solidFill>
-                  <a:schemeClr val="tx1"/>
-                </a:solidFill>
-              </a:rPr>
-              <a:t>tres</a:t>
-            </a:r>
-            <a:r>
-              <a:rPr dirty="0">
-                <a:solidFill>
-                  <a:schemeClr val="tx1"/>
-                </a:solidFill>
-              </a:rPr>
-              <a:t> </a:t>
-            </a:r>
-            <a:r>
-              <a:rPr dirty="0" err="1">
-                <a:solidFill>
-                  <a:schemeClr val="tx1"/>
-                </a:solidFill>
-              </a:rPr>
-              <a:t>palancas</a:t>
-            </a:r>
-            <a:r>
-              <a:rPr dirty="0">
-                <a:solidFill>
-                  <a:schemeClr val="tx1"/>
-                </a:solidFill>
-              </a:rPr>
-              <a:t>: internet </a:t>
-            </a:r>
-            <a:r>
-              <a:rPr dirty="0" err="1">
-                <a:solidFill>
-                  <a:schemeClr val="tx1"/>
-                </a:solidFill>
-              </a:rPr>
-              <a:t>en</a:t>
-            </a:r>
-            <a:r>
-              <a:rPr dirty="0">
-                <a:solidFill>
-                  <a:schemeClr val="tx1"/>
-                </a:solidFill>
-              </a:rPr>
-              <a:t> </a:t>
-            </a:r>
-            <a:r>
-              <a:rPr dirty="0" err="1">
-                <a:solidFill>
-                  <a:schemeClr val="tx1"/>
-                </a:solidFill>
-              </a:rPr>
-              <a:t>quintil</a:t>
-            </a:r>
-            <a:r>
-              <a:rPr dirty="0">
-                <a:solidFill>
-                  <a:schemeClr val="tx1"/>
-                </a:solidFill>
-              </a:rPr>
-              <a:t> I, </a:t>
-            </a:r>
-            <a:r>
-              <a:rPr dirty="0" err="1">
-                <a:solidFill>
-                  <a:schemeClr val="tx1"/>
-                </a:solidFill>
-              </a:rPr>
-              <a:t>educación</a:t>
-            </a:r>
-            <a:r>
-              <a:rPr dirty="0">
-                <a:solidFill>
-                  <a:schemeClr val="tx1"/>
-                </a:solidFill>
-              </a:rPr>
-              <a:t> superior completa y </a:t>
-            </a:r>
-            <a:r>
-              <a:rPr dirty="0" err="1">
-                <a:solidFill>
-                  <a:schemeClr val="tx1"/>
-                </a:solidFill>
-              </a:rPr>
-              <a:t>empleo</a:t>
-            </a:r>
-            <a:r>
-              <a:rPr dirty="0">
-                <a:solidFill>
-                  <a:schemeClr val="tx1"/>
-                </a:solidFill>
-              </a:rPr>
-              <a:t> formal.</a:t>
-            </a:r>
-          </a:p>
-          <a:p>
-            <a:r>
-              <a:rPr dirty="0">
-                <a:solidFill>
-                  <a:schemeClr val="tx1"/>
-                </a:solidFill>
-              </a:rPr>
-              <a:t>• Tres </a:t>
-            </a:r>
-            <a:r>
-              <a:rPr dirty="0" err="1">
-                <a:solidFill>
-                  <a:schemeClr val="tx1"/>
-                </a:solidFill>
-              </a:rPr>
-              <a:t>escenarios</a:t>
-            </a:r>
-            <a:r>
-              <a:rPr dirty="0">
-                <a:solidFill>
-                  <a:schemeClr val="tx1"/>
-                </a:solidFill>
-              </a:rPr>
-              <a:t> </a:t>
-            </a:r>
-            <a:r>
-              <a:rPr dirty="0" err="1">
-                <a:solidFill>
-                  <a:schemeClr val="tx1"/>
-                </a:solidFill>
-              </a:rPr>
-              <a:t>ficticios</a:t>
-            </a:r>
-            <a:r>
-              <a:rPr dirty="0">
-                <a:solidFill>
-                  <a:schemeClr val="tx1"/>
-                </a:solidFill>
-              </a:rPr>
-              <a:t> — E1 </a:t>
-            </a:r>
-            <a:r>
-              <a:rPr dirty="0" err="1">
-                <a:solidFill>
-                  <a:schemeClr val="tx1"/>
-                </a:solidFill>
-              </a:rPr>
-              <a:t>conectividad</a:t>
-            </a:r>
-            <a:r>
-              <a:rPr dirty="0">
-                <a:solidFill>
-                  <a:schemeClr val="tx1"/>
-                </a:solidFill>
-              </a:rPr>
-              <a:t> · E2 </a:t>
-            </a:r>
-            <a:r>
-              <a:rPr dirty="0" err="1">
-                <a:solidFill>
-                  <a:schemeClr val="tx1"/>
-                </a:solidFill>
-              </a:rPr>
-              <a:t>educación</a:t>
-            </a:r>
-            <a:r>
-              <a:rPr dirty="0">
-                <a:solidFill>
-                  <a:schemeClr val="tx1"/>
-                </a:solidFill>
-              </a:rPr>
-              <a:t> al 40% · E3 </a:t>
-            </a:r>
-            <a:r>
-              <a:rPr dirty="0" err="1">
-                <a:solidFill>
-                  <a:schemeClr val="tx1"/>
-                </a:solidFill>
-              </a:rPr>
-              <a:t>paquete</a:t>
-            </a:r>
-            <a:r>
-              <a:rPr dirty="0">
-                <a:solidFill>
-                  <a:schemeClr val="tx1"/>
-                </a:solidFill>
-              </a:rPr>
-              <a:t> </a:t>
-            </a:r>
-            <a:r>
-              <a:rPr dirty="0" err="1">
-                <a:solidFill>
-                  <a:schemeClr val="tx1"/>
-                </a:solidFill>
-              </a:rPr>
-              <a:t>integrado</a:t>
-            </a:r>
-            <a:r>
-              <a:rPr dirty="0">
-                <a:solidFill>
-                  <a:schemeClr val="tx1"/>
-                </a:solidFill>
-              </a:rPr>
-              <a:t> — </a:t>
-            </a:r>
-            <a:r>
-              <a:rPr dirty="0" err="1">
-                <a:solidFill>
-                  <a:schemeClr val="tx1"/>
-                </a:solidFill>
-              </a:rPr>
-              <a:t>sobre</a:t>
-            </a:r>
-            <a:r>
-              <a:rPr dirty="0">
-                <a:solidFill>
-                  <a:schemeClr val="tx1"/>
-                </a:solidFill>
-              </a:rPr>
-              <a:t> un </a:t>
-            </a:r>
-            <a:r>
-              <a:rPr dirty="0" err="1">
-                <a:solidFill>
-                  <a:schemeClr val="tx1"/>
-                </a:solidFill>
-              </a:rPr>
-              <a:t>mismo</a:t>
-            </a:r>
-            <a:r>
-              <a:rPr dirty="0">
-                <a:solidFill>
-                  <a:schemeClr val="tx1"/>
-                </a:solidFill>
-              </a:rPr>
-              <a:t> baseline </a:t>
-            </a:r>
-            <a:r>
-              <a:rPr dirty="0" err="1">
-                <a:solidFill>
-                  <a:schemeClr val="tx1"/>
-                </a:solidFill>
-              </a:rPr>
-              <a:t>oficial</a:t>
-            </a:r>
-            <a:r>
-              <a:rPr dirty="0">
-                <a:solidFill>
-                  <a:schemeClr val="tx1"/>
-                </a:solidFill>
-              </a:rPr>
-              <a:t>.</a:t>
-            </a:r>
-          </a:p>
-          <a:p>
-            <a:r>
-              <a:rPr dirty="0">
-                <a:solidFill>
-                  <a:schemeClr val="tx1"/>
-                </a:solidFill>
-              </a:rPr>
-              <a:t>• Plataforma </a:t>
-            </a:r>
-            <a:r>
-              <a:rPr dirty="0" err="1">
-                <a:solidFill>
-                  <a:schemeClr val="tx1"/>
-                </a:solidFill>
-              </a:rPr>
-              <a:t>pública</a:t>
-            </a:r>
-            <a:r>
-              <a:rPr dirty="0">
-                <a:solidFill>
-                  <a:schemeClr val="tx1"/>
-                </a:solidFill>
-              </a:rPr>
-              <a:t>: </a:t>
-            </a:r>
-            <a:r>
-              <a:rPr dirty="0" err="1">
-                <a:solidFill>
-                  <a:schemeClr val="tx1"/>
-                </a:solidFill>
-              </a:rPr>
-              <a:t>eph-analyzer.streamlit.app</a:t>
-            </a:r>
-            <a:r>
-              <a:rPr dirty="0">
-                <a:solidFill>
-                  <a:schemeClr val="tx1"/>
-                </a:solidFill>
-              </a:rPr>
-              <a:t>/GEMEPH</a:t>
+              <a:t>• Permite mover tres "palancas" de política: internet en hogares de menores ingresos, educación universitaria y empleo formal.</a:t>
+            </a:r>
+          </a:p>
+          <a:p>
+            <a:r>
+              <a:t>• Compara tres escenarios ficticios (conectividad, educación e integrado) sobre el mismo punto de partida oficial.</a:t>
+            </a:r>
+          </a:p>
+          <a:p>
+            <a:r>
+              <a:t>• Todo se consulta en una plataforma abierta: eph-analyzer.streamlit.app/GEMEPH</a:t>
             </a:r>
           </a:p>
         </p:txBody>

</xml_diff>

<commit_message>
Clarify slide 4 results wording in GEMEPH presentation
Co-authored-by: Claudio Larrea <claudiomlarrea@users.noreply.github.com>
</commit_message>
<xml_diff>
--- a/JORNADAS IA 2026/Presentacion_FINAL.pptx
+++ b/JORNADAS IA 2026/Presentacion_FINAL.pptx
@@ -5156,28 +5156,7 @@
               </a:spcAft>
             </a:pPr>
             <a:r>
-              <a:rPr dirty="0" err="1">
-                <a:solidFill>
-                  <a:schemeClr val="tx1"/>
-                </a:solidFill>
-              </a:rPr>
-              <a:t>Resultados</a:t>
-            </a:r>
-            <a:r>
-              <a:rPr dirty="0">
-                <a:solidFill>
-                  <a:schemeClr val="tx1"/>
-                </a:solidFill>
-              </a:rPr>
-              <a:t> del baseline </a:t>
-            </a:r>
-            <a:r>
-              <a:rPr dirty="0" err="1">
-                <a:solidFill>
-                  <a:schemeClr val="tx1"/>
-                </a:solidFill>
-              </a:rPr>
-              <a:t>oficial</a:t>
+              <a:t>¿Qué muestran los datos oficiales?</a:t>
             </a:r>
             <a:endParaRPr dirty="0">
               <a:solidFill>
@@ -5192,68 +5171,7 @@
               </a:spcAft>
             </a:pPr>
             <a:r>
-              <a:rPr dirty="0">
-                <a:solidFill>
-                  <a:schemeClr val="tx1"/>
-                </a:solidFill>
-              </a:rPr>
-              <a:t>• </a:t>
-            </a:r>
-            <a:r>
-              <a:rPr dirty="0" err="1">
-                <a:solidFill>
-                  <a:schemeClr val="tx1"/>
-                </a:solidFill>
-              </a:rPr>
-              <a:t>Exclusión</a:t>
-            </a:r>
-            <a:r>
-              <a:rPr dirty="0">
-                <a:solidFill>
-                  <a:schemeClr val="tx1"/>
-                </a:solidFill>
-              </a:rPr>
-              <a:t> digital: 0,62 — 54% </a:t>
-            </a:r>
-            <a:r>
-              <a:rPr dirty="0" err="1">
-                <a:solidFill>
-                  <a:schemeClr val="tx1"/>
-                </a:solidFill>
-              </a:rPr>
-              <a:t>en</a:t>
-            </a:r>
-            <a:r>
-              <a:rPr dirty="0">
-                <a:solidFill>
-                  <a:schemeClr val="tx1"/>
-                </a:solidFill>
-              </a:rPr>
-              <a:t> </a:t>
-            </a:r>
-            <a:r>
-              <a:rPr dirty="0" err="1">
-                <a:solidFill>
-                  <a:schemeClr val="tx1"/>
-                </a:solidFill>
-              </a:rPr>
-              <a:t>exclusión</a:t>
-            </a:r>
-            <a:r>
-              <a:rPr dirty="0">
-                <a:solidFill>
-                  <a:schemeClr val="tx1"/>
-                </a:solidFill>
-              </a:rPr>
-              <a:t> </a:t>
-            </a:r>
-            <a:r>
-              <a:rPr dirty="0" err="1">
-                <a:solidFill>
-                  <a:schemeClr val="tx1"/>
-                </a:solidFill>
-              </a:rPr>
-              <a:t>alta.</a:t>
+              <a:t>• En Argentina urbana, la exclusión digital es alta: índice 0,62 y casi 54 de cada 100 personas en exclusión alta.</a:t>
             </a:r>
             <a:endParaRPr dirty="0">
               <a:solidFill>
@@ -5268,44 +5186,7 @@
               </a:spcAft>
             </a:pPr>
             <a:r>
-              <a:rPr dirty="0">
-                <a:solidFill>
-                  <a:schemeClr val="tx1"/>
-                </a:solidFill>
-              </a:rPr>
-              <a:t>• </a:t>
-            </a:r>
-            <a:r>
-              <a:rPr dirty="0" err="1">
-                <a:solidFill>
-                  <a:schemeClr val="tx1"/>
-                </a:solidFill>
-              </a:rPr>
-              <a:t>Vulnerabilidad</a:t>
-            </a:r>
-            <a:r>
-              <a:rPr dirty="0">
-                <a:solidFill>
-                  <a:schemeClr val="tx1"/>
-                </a:solidFill>
-              </a:rPr>
-              <a:t>: 0,27 · </a:t>
-            </a:r>
-            <a:r>
-              <a:rPr dirty="0" err="1">
-                <a:solidFill>
-                  <a:schemeClr val="tx1"/>
-                </a:solidFill>
-              </a:rPr>
-              <a:t>Movilidad</a:t>
-            </a:r>
-            <a:r>
-              <a:rPr dirty="0">
-                <a:solidFill>
-                  <a:schemeClr val="tx1"/>
-                </a:solidFill>
-              </a:rPr>
-              <a:t> proxy: 0,48.</a:t>
+              <a:t>• Hay vulnerabilidad social (0,27) y una movilidad social moderada (0,48).</a:t>
             </a:r>
           </a:p>
           <a:p>
@@ -5315,224 +5196,17 @@
               </a:spcAft>
             </a:pPr>
             <a:r>
-              <a:rPr dirty="0">
-                <a:solidFill>
-                  <a:schemeClr val="tx1"/>
-                </a:solidFill>
-              </a:rPr>
-              <a:t>• Fuerte </a:t>
-            </a:r>
-            <a:r>
-              <a:rPr dirty="0" err="1">
-                <a:solidFill>
-                  <a:schemeClr val="tx1"/>
-                </a:solidFill>
-              </a:rPr>
-              <a:t>heterogeneidad</a:t>
-            </a:r>
-            <a:r>
-              <a:rPr dirty="0">
-                <a:solidFill>
-                  <a:schemeClr val="tx1"/>
-                </a:solidFill>
-              </a:rPr>
-              <a:t> entre </a:t>
-            </a:r>
-            <a:r>
-              <a:rPr dirty="0" err="1">
-                <a:solidFill>
-                  <a:schemeClr val="tx1"/>
-                </a:solidFill>
-              </a:rPr>
-              <a:t>los</a:t>
-            </a:r>
-            <a:r>
-              <a:rPr dirty="0">
-                <a:solidFill>
-                  <a:schemeClr val="tx1"/>
-                </a:solidFill>
-              </a:rPr>
-              <a:t> 31 </a:t>
-            </a:r>
-            <a:r>
-              <a:rPr dirty="0" err="1">
-                <a:solidFill>
-                  <a:schemeClr val="tx1"/>
-                </a:solidFill>
-              </a:rPr>
-              <a:t>aglomerados</a:t>
-            </a:r>
-            <a:r>
-              <a:rPr dirty="0">
-                <a:solidFill>
-                  <a:schemeClr val="tx1"/>
-                </a:solidFill>
-              </a:rPr>
-              <a:t> </a:t>
-            </a:r>
-            <a:r>
-              <a:rPr dirty="0" err="1">
-                <a:solidFill>
-                  <a:schemeClr val="tx1"/>
-                </a:solidFill>
-              </a:rPr>
-              <a:t>urbanos</a:t>
-            </a:r>
-            <a:r>
-              <a:rPr dirty="0">
-                <a:solidFill>
-                  <a:schemeClr val="tx1"/>
-                </a:solidFill>
-              </a:rPr>
-              <a:t>.</a:t>
-            </a:r>
-          </a:p>
-          <a:p>
-            <a:r>
-              <a:rPr dirty="0">
-                <a:solidFill>
-                  <a:schemeClr val="tx1"/>
-                </a:solidFill>
-              </a:rPr>
-              <a:t>• Ushuaia–Río Grande </a:t>
-            </a:r>
-            <a:r>
-              <a:rPr dirty="0" err="1">
-                <a:solidFill>
-                  <a:schemeClr val="tx1"/>
-                </a:solidFill>
-              </a:rPr>
-              <a:t>lidera</a:t>
-            </a:r>
-            <a:r>
-              <a:rPr dirty="0">
-                <a:solidFill>
-                  <a:schemeClr val="tx1"/>
-                </a:solidFill>
-              </a:rPr>
-              <a:t> el ranking; Gran Córdoba, el valor </a:t>
-            </a:r>
-            <a:r>
-              <a:rPr dirty="0" err="1">
-                <a:solidFill>
-                  <a:schemeClr val="tx1"/>
-                </a:solidFill>
-              </a:rPr>
-              <a:t>más</a:t>
-            </a:r>
-            <a:r>
-              <a:rPr dirty="0">
-                <a:solidFill>
-                  <a:schemeClr val="tx1"/>
-                </a:solidFill>
-              </a:rPr>
-              <a:t> bajo.</a:t>
-            </a:r>
-          </a:p>
-          <a:p>
-            <a:r>
-              <a:rPr dirty="0">
-                <a:solidFill>
-                  <a:schemeClr val="tx1"/>
-                </a:solidFill>
-              </a:rPr>
-              <a:t>• El </a:t>
-            </a:r>
-            <a:r>
-              <a:rPr dirty="0" err="1">
-                <a:solidFill>
-                  <a:schemeClr val="tx1"/>
-                </a:solidFill>
-              </a:rPr>
-              <a:t>gemelo</a:t>
-            </a:r>
-            <a:r>
-              <a:rPr dirty="0">
-                <a:solidFill>
-                  <a:schemeClr val="tx1"/>
-                </a:solidFill>
-              </a:rPr>
-              <a:t> </a:t>
-            </a:r>
-            <a:r>
-              <a:rPr dirty="0" err="1">
-                <a:solidFill>
-                  <a:schemeClr val="tx1"/>
-                </a:solidFill>
-              </a:rPr>
-              <a:t>actualiza</a:t>
-            </a:r>
-            <a:r>
-              <a:rPr dirty="0">
-                <a:solidFill>
-                  <a:schemeClr val="tx1"/>
-                </a:solidFill>
-              </a:rPr>
-              <a:t> </a:t>
-            </a:r>
-            <a:r>
-              <a:rPr dirty="0" err="1">
-                <a:solidFill>
-                  <a:schemeClr val="tx1"/>
-                </a:solidFill>
-              </a:rPr>
-              <a:t>estas</a:t>
-            </a:r>
-            <a:r>
-              <a:rPr dirty="0">
-                <a:solidFill>
-                  <a:schemeClr val="tx1"/>
-                </a:solidFill>
-              </a:rPr>
-              <a:t> </a:t>
-            </a:r>
-            <a:r>
-              <a:rPr dirty="0" err="1">
-                <a:solidFill>
-                  <a:schemeClr val="tx1"/>
-                </a:solidFill>
-              </a:rPr>
-              <a:t>brechas</a:t>
-            </a:r>
-            <a:r>
-              <a:rPr dirty="0">
-                <a:solidFill>
-                  <a:schemeClr val="tx1"/>
-                </a:solidFill>
-              </a:rPr>
-              <a:t> con </a:t>
-            </a:r>
-            <a:r>
-              <a:rPr dirty="0" err="1">
-                <a:solidFill>
-                  <a:schemeClr val="tx1"/>
-                </a:solidFill>
-              </a:rPr>
-              <a:t>cada</a:t>
-            </a:r>
-            <a:r>
-              <a:rPr dirty="0">
-                <a:solidFill>
-                  <a:schemeClr val="tx1"/>
-                </a:solidFill>
-              </a:rPr>
-              <a:t> </a:t>
-            </a:r>
-            <a:r>
-              <a:rPr dirty="0" err="1">
-                <a:solidFill>
-                  <a:schemeClr val="tx1"/>
-                </a:solidFill>
-              </a:rPr>
-              <a:t>onda</a:t>
-            </a:r>
-            <a:r>
-              <a:rPr dirty="0">
-                <a:solidFill>
-                  <a:schemeClr val="tx1"/>
-                </a:solidFill>
-              </a:rPr>
-              <a:t> del INDEC.</a:t>
+              <a:t>• Las diferencias entre ciudades son claras: no todos los aglomerados parten del mismo lugar.</a:t>
+            </a:r>
+          </a:p>
+          <a:p>
+            <a:r>
+              <a:t>• Ushuaia–Río Grande concentra más exclusión; Gran Córdoba, menos.</a:t>
+            </a:r>
+          </a:p>
+          <a:p>
+            <a:r>
+              <a:t>• GEMEPH actualiza estas brechas cada vez que el INDEC publica nueva EPH.</a:t>
             </a:r>
           </a:p>
         </p:txBody>

</xml_diff>

<commit_message>
Refine slide 4 text for chart layout clarity
Co-authored-by: Claudio Larrea <claudiomlarrea@users.noreply.github.com>
</commit_message>
<xml_diff>
--- a/JORNADAS IA 2026/Presentacion_FINAL.pptx
+++ b/JORNADAS IA 2026/Presentacion_FINAL.pptx
@@ -5118,7 +5118,7 @@
         <p:spPr>
           <a:xfrm>
             <a:off x="548640" y="1920240"/>
-            <a:ext cx="5440680" cy="4206240"/>
+            <a:ext cx="5577840" cy="4206240"/>
           </a:xfrm>
           <a:prstGeom prst="roundRect">
             <a:avLst/>
@@ -5171,7 +5171,7 @@
               </a:spcAft>
             </a:pPr>
             <a:r>
-              <a:t>• En Argentina urbana, la exclusión digital es alta: índice 0,62 y casi 54 de cada 100 personas en exclusión alta.</a:t>
+              <a:t>• Exclusión digital alta: índice 0,62 (casi 54 de cada 100 personas).</a:t>
             </a:r>
             <a:endParaRPr dirty="0">
               <a:solidFill>
@@ -5186,7 +5186,7 @@
               </a:spcAft>
             </a:pPr>
             <a:r>
-              <a:t>• Hay vulnerabilidad social (0,27) y una movilidad social moderada (0,48).</a:t>
+              <a:t>• Vulnerabilidad social: 0,27. Movilidad social: 0,48.</a:t>
             </a:r>
           </a:p>
           <a:p>
@@ -5196,17 +5196,17 @@
               </a:spcAft>
             </a:pPr>
             <a:r>
-              <a:t>• Las diferencias entre ciudades son claras: no todos los aglomerados parten del mismo lugar.</a:t>
-            </a:r>
-          </a:p>
-          <a:p>
-            <a:r>
-              <a:t>• Ushuaia–Río Grande concentra más exclusión; Gran Córdoba, menos.</a:t>
-            </a:r>
-          </a:p>
-          <a:p>
-            <a:r>
-              <a:t>• GEMEPH actualiza estas brechas cada vez que el INDEC publica nueva EPH.</a:t>
+              <a:t>• Las ciudades no parten iguales: hay brechas claras entre aglomerados.</a:t>
+            </a:r>
+          </a:p>
+          <a:p>
+            <a:r>
+              <a:t>• Más exclusión: Ushuaia–Río Grande. Menos: Gran Córdoba.</a:t>
+            </a:r>
+          </a:p>
+          <a:p>
+            <a:r>
+              <a:t>• GEMEPH actualiza estos resultados con cada nueva EPH del INDEC.</a:t>
             </a:r>
           </a:p>
         </p:txBody>

</xml_diff>

<commit_message>
Clarify slide 5 scenario conclusions wording
Co-authored-by: Claudio Larrea <claudiomlarrea@users.noreply.github.com>
</commit_message>
<xml_diff>
--- a/JORNADAS IA 2026/Presentacion_FINAL.pptx
+++ b/JORNADAS IA 2026/Presentacion_FINAL.pptx
@@ -5642,7 +5642,7 @@
         <p:spPr>
           <a:xfrm>
             <a:off x="548640" y="1920240"/>
-            <a:ext cx="5440680" cy="4206240"/>
+            <a:ext cx="5577840" cy="4206240"/>
           </a:xfrm>
           <a:prstGeom prst="roundRect">
             <a:avLst/>
@@ -5680,52 +5680,7 @@
               </a:spcAft>
             </a:pPr>
             <a:r>
-              <a:rPr dirty="0">
-                <a:solidFill>
-                  <a:schemeClr val="tx1"/>
-                </a:solidFill>
-              </a:rPr>
-              <a:t>Tres </a:t>
-            </a:r>
-            <a:r>
-              <a:rPr dirty="0" err="1">
-                <a:solidFill>
-                  <a:schemeClr val="tx1"/>
-                </a:solidFill>
-              </a:rPr>
-              <a:t>escenarios</a:t>
-            </a:r>
-            <a:r>
-              <a:rPr dirty="0">
-                <a:solidFill>
-                  <a:schemeClr val="tx1"/>
-                </a:solidFill>
-              </a:rPr>
-              <a:t>, </a:t>
-            </a:r>
-            <a:r>
-              <a:rPr dirty="0" err="1">
-                <a:solidFill>
-                  <a:schemeClr val="tx1"/>
-                </a:solidFill>
-              </a:rPr>
-              <a:t>tres</a:t>
-            </a:r>
-            <a:r>
-              <a:rPr dirty="0">
-                <a:solidFill>
-                  <a:schemeClr val="tx1"/>
-                </a:solidFill>
-              </a:rPr>
-              <a:t> </a:t>
-            </a:r>
-            <a:r>
-              <a:rPr dirty="0" err="1">
-                <a:solidFill>
-                  <a:schemeClr val="tx1"/>
-                </a:solidFill>
-              </a:rPr>
-              <a:t>lecciones</a:t>
+              <a:t>¿Qué aprendemos de los tres escenarios?</a:t>
             </a:r>
             <a:endParaRPr dirty="0">
               <a:solidFill>
@@ -5740,76 +5695,7 @@
               </a:spcAft>
             </a:pPr>
             <a:r>
-              <a:rPr dirty="0">
-                <a:solidFill>
-                  <a:schemeClr val="tx1"/>
-                </a:solidFill>
-              </a:rPr>
-              <a:t>• E1 </a:t>
-            </a:r>
-            <a:r>
-              <a:rPr dirty="0" err="1">
-                <a:solidFill>
-                  <a:schemeClr val="tx1"/>
-                </a:solidFill>
-              </a:rPr>
-              <a:t>Conectividad</a:t>
-            </a:r>
-            <a:r>
-              <a:rPr dirty="0">
-                <a:solidFill>
-                  <a:schemeClr val="tx1"/>
-                </a:solidFill>
-              </a:rPr>
-              <a:t>: </a:t>
-            </a:r>
-            <a:r>
-              <a:rPr dirty="0" err="1">
-                <a:solidFill>
-                  <a:schemeClr val="tx1"/>
-                </a:solidFill>
-              </a:rPr>
-              <a:t>efecto</a:t>
-            </a:r>
-            <a:r>
-              <a:rPr dirty="0">
-                <a:solidFill>
-                  <a:schemeClr val="tx1"/>
-                </a:solidFill>
-              </a:rPr>
-              <a:t> marginal (</a:t>
-            </a:r>
-            <a:r>
-              <a:rPr dirty="0" err="1">
-                <a:solidFill>
-                  <a:schemeClr val="tx1"/>
-                </a:solidFill>
-              </a:rPr>
-              <a:t>quintil</a:t>
-            </a:r>
-            <a:r>
-              <a:rPr dirty="0">
-                <a:solidFill>
-                  <a:schemeClr val="tx1"/>
-                </a:solidFill>
-              </a:rPr>
-              <a:t> bajo </a:t>
-            </a:r>
-            <a:r>
-              <a:rPr dirty="0" err="1">
-                <a:solidFill>
-                  <a:schemeClr val="tx1"/>
-                </a:solidFill>
-              </a:rPr>
-              <a:t>ya</a:t>
-            </a:r>
-            <a:r>
-              <a:rPr dirty="0">
-                <a:solidFill>
-                  <a:schemeClr val="tx1"/>
-                </a:solidFill>
-              </a:rPr>
-              <a:t> al 94% de internet).</a:t>
+              <a:t>• E1 — Solo más internet: cambia poco, porque el quintil de menores ingresos ya tiene ~94% de conexión.</a:t>
             </a:r>
           </a:p>
           <a:p>
@@ -5819,76 +5705,7 @@
               </a:spcAft>
             </a:pPr>
             <a:r>
-              <a:rPr dirty="0">
-                <a:solidFill>
-                  <a:schemeClr val="tx1"/>
-                </a:solidFill>
-              </a:rPr>
-              <a:t>• E2 </a:t>
-            </a:r>
-            <a:r>
-              <a:rPr dirty="0" err="1">
-                <a:solidFill>
-                  <a:schemeClr val="tx1"/>
-                </a:solidFill>
-              </a:rPr>
-              <a:t>Educación</a:t>
-            </a:r>
-            <a:r>
-              <a:rPr dirty="0">
-                <a:solidFill>
-                  <a:schemeClr val="tx1"/>
-                </a:solidFill>
-              </a:rPr>
-              <a:t> al 40%: mayor </a:t>
-            </a:r>
-            <a:r>
-              <a:rPr dirty="0" err="1">
-                <a:solidFill>
-                  <a:schemeClr val="tx1"/>
-                </a:solidFill>
-              </a:rPr>
-              <a:t>impacto</a:t>
-            </a:r>
-            <a:r>
-              <a:rPr dirty="0">
-                <a:solidFill>
-                  <a:schemeClr val="tx1"/>
-                </a:solidFill>
-              </a:rPr>
-              <a:t> </a:t>
-            </a:r>
-            <a:r>
-              <a:rPr dirty="0" err="1">
-                <a:solidFill>
-                  <a:schemeClr val="tx1"/>
-                </a:solidFill>
-              </a:rPr>
-              <a:t>en</a:t>
-            </a:r>
-            <a:r>
-              <a:rPr dirty="0">
-                <a:solidFill>
-                  <a:schemeClr val="tx1"/>
-                </a:solidFill>
-              </a:rPr>
-              <a:t> </a:t>
-            </a:r>
-            <a:r>
-              <a:rPr dirty="0" err="1">
-                <a:solidFill>
-                  <a:schemeClr val="tx1"/>
-                </a:solidFill>
-              </a:rPr>
-              <a:t>movilidad</a:t>
-            </a:r>
-            <a:r>
-              <a:rPr dirty="0">
-                <a:solidFill>
-                  <a:schemeClr val="tx1"/>
-                </a:solidFill>
-              </a:rPr>
-              <a:t> proxy (+0,04).</a:t>
+              <a:t>• E2 — Más educación superior (al 40%): mejora con más fuerza la movilidad social (+0,04).</a:t>
             </a:r>
           </a:p>
           <a:p>
@@ -5898,272 +5715,17 @@
               </a:spcAft>
             </a:pPr>
             <a:r>
-              <a:rPr dirty="0">
-                <a:solidFill>
-                  <a:schemeClr val="tx1"/>
-                </a:solidFill>
-              </a:rPr>
-              <a:t>• E3 </a:t>
-            </a:r>
-            <a:r>
-              <a:rPr dirty="0" err="1">
-                <a:solidFill>
-                  <a:schemeClr val="tx1"/>
-                </a:solidFill>
-              </a:rPr>
-              <a:t>Paquete</a:t>
-            </a:r>
-            <a:r>
-              <a:rPr dirty="0">
-                <a:solidFill>
-                  <a:schemeClr val="tx1"/>
-                </a:solidFill>
-              </a:rPr>
-              <a:t> </a:t>
-            </a:r>
-            <a:r>
-              <a:rPr dirty="0" err="1">
-                <a:solidFill>
-                  <a:schemeClr val="tx1"/>
-                </a:solidFill>
-              </a:rPr>
-              <a:t>integrado</a:t>
-            </a:r>
-            <a:r>
-              <a:rPr dirty="0">
-                <a:solidFill>
-                  <a:schemeClr val="tx1"/>
-                </a:solidFill>
-              </a:rPr>
-              <a:t>: </a:t>
-            </a:r>
-            <a:r>
-              <a:rPr dirty="0" err="1">
-                <a:solidFill>
-                  <a:schemeClr val="tx1"/>
-                </a:solidFill>
-              </a:rPr>
-              <a:t>efecto</a:t>
-            </a:r>
-            <a:r>
-              <a:rPr dirty="0">
-                <a:solidFill>
-                  <a:schemeClr val="tx1"/>
-                </a:solidFill>
-              </a:rPr>
-              <a:t> </a:t>
-            </a:r>
-            <a:r>
-              <a:rPr dirty="0" err="1">
-                <a:solidFill>
-                  <a:schemeClr val="tx1"/>
-                </a:solidFill>
-              </a:rPr>
-              <a:t>más</a:t>
-            </a:r>
-            <a:r>
-              <a:rPr dirty="0">
-                <a:solidFill>
-                  <a:schemeClr val="tx1"/>
-                </a:solidFill>
-              </a:rPr>
-              <a:t> </a:t>
-            </a:r>
-            <a:r>
-              <a:rPr dirty="0" err="1">
-                <a:solidFill>
-                  <a:schemeClr val="tx1"/>
-                </a:solidFill>
-              </a:rPr>
-              <a:t>equilibrado</a:t>
-            </a:r>
-            <a:r>
-              <a:rPr dirty="0">
-                <a:solidFill>
-                  <a:schemeClr val="tx1"/>
-                </a:solidFill>
-              </a:rPr>
-              <a:t>; </a:t>
-            </a:r>
-            <a:r>
-              <a:rPr dirty="0" err="1">
-                <a:solidFill>
-                  <a:schemeClr val="tx1"/>
-                </a:solidFill>
-              </a:rPr>
-              <a:t>exclusión</a:t>
-            </a:r>
-            <a:r>
-              <a:rPr dirty="0">
-                <a:solidFill>
-                  <a:schemeClr val="tx1"/>
-                </a:solidFill>
-              </a:rPr>
-              <a:t> </a:t>
-            </a:r>
-            <a:r>
-              <a:rPr dirty="0" err="1">
-                <a:solidFill>
-                  <a:schemeClr val="tx1"/>
-                </a:solidFill>
-              </a:rPr>
-              <a:t>predicha</a:t>
-            </a:r>
-            <a:r>
-              <a:rPr dirty="0">
-                <a:solidFill>
-                  <a:schemeClr val="tx1"/>
-                </a:solidFill>
-              </a:rPr>
-              <a:t> 5,84%.</a:t>
-            </a:r>
-          </a:p>
-          <a:p>
-            <a:r>
-              <a:rPr dirty="0">
-                <a:solidFill>
-                  <a:schemeClr val="tx1"/>
-                </a:solidFill>
-              </a:rPr>
-              <a:t>• Una sola </a:t>
-            </a:r>
-            <a:r>
-              <a:rPr dirty="0" err="1">
-                <a:solidFill>
-                  <a:schemeClr val="tx1"/>
-                </a:solidFill>
-              </a:rPr>
-              <a:t>palanca</a:t>
-            </a:r>
-            <a:r>
-              <a:rPr dirty="0">
-                <a:solidFill>
-                  <a:schemeClr val="tx1"/>
-                </a:solidFill>
-              </a:rPr>
-              <a:t> digital no basta: </a:t>
-            </a:r>
-            <a:r>
-              <a:rPr dirty="0" err="1">
-                <a:solidFill>
-                  <a:schemeClr val="tx1"/>
-                </a:solidFill>
-              </a:rPr>
-              <a:t>conviene</a:t>
-            </a:r>
-            <a:r>
-              <a:rPr dirty="0">
-                <a:solidFill>
-                  <a:schemeClr val="tx1"/>
-                </a:solidFill>
-              </a:rPr>
-              <a:t> </a:t>
-            </a:r>
-            <a:r>
-              <a:rPr dirty="0" err="1">
-                <a:solidFill>
-                  <a:schemeClr val="tx1"/>
-                </a:solidFill>
-              </a:rPr>
-              <a:t>combinar</a:t>
-            </a:r>
-            <a:r>
-              <a:rPr dirty="0">
-                <a:solidFill>
-                  <a:schemeClr val="tx1"/>
-                </a:solidFill>
-              </a:rPr>
-              <a:t> </a:t>
-            </a:r>
-            <a:r>
-              <a:rPr dirty="0" err="1">
-                <a:solidFill>
-                  <a:schemeClr val="tx1"/>
-                </a:solidFill>
-              </a:rPr>
-              <a:t>políticas</a:t>
-            </a:r>
-            <a:r>
-              <a:rPr dirty="0">
-                <a:solidFill>
-                  <a:schemeClr val="tx1"/>
-                </a:solidFill>
-              </a:rPr>
-              <a:t>.</a:t>
-            </a:r>
-          </a:p>
-          <a:p>
-            <a:r>
-              <a:rPr dirty="0">
-                <a:solidFill>
-                  <a:schemeClr val="tx1"/>
-                </a:solidFill>
-              </a:rPr>
-              <a:t>• El </a:t>
-            </a:r>
-            <a:r>
-              <a:rPr dirty="0" err="1">
-                <a:solidFill>
-                  <a:schemeClr val="tx1"/>
-                </a:solidFill>
-              </a:rPr>
-              <a:t>gemelo</a:t>
-            </a:r>
-            <a:r>
-              <a:rPr dirty="0">
-                <a:solidFill>
-                  <a:schemeClr val="tx1"/>
-                </a:solidFill>
-              </a:rPr>
-              <a:t> </a:t>
-            </a:r>
-            <a:r>
-              <a:rPr dirty="0" err="1">
-                <a:solidFill>
-                  <a:schemeClr val="tx1"/>
-                </a:solidFill>
-              </a:rPr>
-              <a:t>anticipa</a:t>
-            </a:r>
-            <a:r>
-              <a:rPr dirty="0">
-                <a:solidFill>
-                  <a:schemeClr val="tx1"/>
-                </a:solidFill>
-              </a:rPr>
-              <a:t> magnitudes de </a:t>
-            </a:r>
-            <a:r>
-              <a:rPr dirty="0" err="1">
-                <a:solidFill>
-                  <a:schemeClr val="tx1"/>
-                </a:solidFill>
-              </a:rPr>
-              <a:t>cambio</a:t>
-            </a:r>
-            <a:r>
-              <a:rPr dirty="0">
-                <a:solidFill>
-                  <a:schemeClr val="tx1"/>
-                </a:solidFill>
-              </a:rPr>
-              <a:t> sin </a:t>
-            </a:r>
-            <a:r>
-              <a:rPr dirty="0" err="1">
-                <a:solidFill>
-                  <a:schemeClr val="tx1"/>
-                </a:solidFill>
-              </a:rPr>
-              <a:t>reemplazar</a:t>
-            </a:r>
-            <a:r>
-              <a:rPr dirty="0">
-                <a:solidFill>
-                  <a:schemeClr val="tx1"/>
-                </a:solidFill>
-              </a:rPr>
-              <a:t> al INDEC.</a:t>
+              <a:t>• E3 — Combinar educación, empleo formal e internet: el resultado más equilibrado (exclusión predicha 5,84%).</a:t>
+            </a:r>
+          </a:p>
+          <a:p>
+            <a:r>
+              <a:t>• Conclusión: una sola medida digital no alcanza; conviene combinar políticas.</a:t>
+            </a:r>
+          </a:p>
+          <a:p>
+            <a:r>
+              <a:t>• GEMEPH anticipa magnitudes de cambio sin reemplazar al INDEC.</a:t>
             </a:r>
           </a:p>
         </p:txBody>

</xml_diff>

<commit_message>
Slide 3: method text plus GEMEPH system screenshot
Also lock slide 2 to the approved objective/context wording.

Co-authored-by: Claudio Larrea <claudiomlarrea@users.noreply.github.com>
</commit_message>
<xml_diff>
--- a/JORNADAS IA 2026/Presentacion_FINAL.pptx
+++ b/JORNADAS IA 2026/Presentacion_FINAL.pptx
@@ -4219,7 +4219,7 @@
               </a:spcAft>
             </a:pPr>
             <a:r>
-              <a:t>¿Para qué sirve un gemelo digital de la EPH?</a:t>
+              <a:t>¿Qué problema o pregunta aborda el trabajo?</a:t>
             </a:r>
           </a:p>
           <a:p>
@@ -4229,7 +4229,7 @@
               </a:spcAft>
             </a:pPr>
             <a:r>
-              <a:t>• La EPH del INDEC nos dice cómo viven, trabajan y se conectan los hogares urbanos de Argentina.</a:t>
+              <a:t>• Objetivo general: construir y validar GEMEPH, un gemelo digital que, con datos oficiales de la EPH-INDEC, permita simular qué pasaría si mejoran la conectividad, la educación o el empleo formal, y comparar exclusión digital y vulnerabilidad entre ciudades.</a:t>
             </a:r>
           </a:p>
           <a:p>
@@ -4239,7 +4239,7 @@
               </a:spcAft>
             </a:pPr>
             <a:r>
-              <a:t>• Pero solo muestra lo que ya ocurre: no responde qué pasaría si más gente tuviera internet, más educación o empleo formal.</a:t>
+              <a:t>• Contexto: la EPH describe bien la realidad actual de los hogares urbanos, pero no permite explorar de forma sistemática escenarios futuros (“qué pasaría si…”). GEMEPH responde a esa limitación sin reemplazar al INDEC.</a:t>
             </a:r>
           </a:p>
           <a:p>
@@ -4249,12 +4249,7 @@
               </a:spcAft>
             </a:pPr>
             <a:r>
-              <a:t>• GEMEPH toma ese dato oficial y permite simular escenarios ("qué pasaría si…") de forma transparente y repetible.</a:t>
-            </a:r>
-          </a:p>
-          <a:p>
-            <a:r>
-              <a:t>• Así, el Observatorio de IA de la UCCuyo puede investigar, enseñar y orientar decisiones con evidencia comparable en 31 ciudades.</a:t>
+              <a:t>• Por qué importa para la UCCuyo / la región: fortalece al Observatorio de IA con una herramienta abierta para investigar, enseñar y orientar decisiones, con evidencia comparable en 31 aglomerados urbanos de Argentina.</a:t>
             </a:r>
           </a:p>
         </p:txBody>
@@ -4642,7 +4637,7 @@
         <p:spPr>
           <a:xfrm>
             <a:off x="548640" y="1920240"/>
-            <a:ext cx="11064240" cy="4206240"/>
+            <a:ext cx="5303520" cy="4206240"/>
           </a:xfrm>
           <a:prstGeom prst="roundRect">
             <a:avLst/>
@@ -4680,7 +4675,7 @@
               </a:spcAft>
             </a:pPr>
             <a:r>
-              <a:t>¿Cómo funciona GEMEPH?</a:t>
+              <a:t>¿Cómo se hizo?</a:t>
             </a:r>
           </a:p>
           <a:p>
@@ -4690,7 +4685,7 @@
               </a:spcAft>
             </a:pPr>
             <a:r>
-              <a:t>• Parte de microdatos oficiales de la EPH (2022–2024, 4.º trimestre, módulo TIC): 114.280 personas, con el peso estadístico del INDEC.</a:t>
+              <a:t>• Se integran microdatos oficiales de la EPH-INDEC (hogar + individuo + módulo TIC) y se construye el estado del gemelo para Argentina y 31 aglomerados.</a:t>
             </a:r>
           </a:p>
           <a:p>
@@ -4700,7 +4695,7 @@
               </a:spcAft>
             </a:pPr>
             <a:r>
-              <a:t>• Calcula indicadores fáciles de interpretar: exclusión digital, vulnerabilidad, movilidad social, empleo, educación e informalidad.</a:t>
+              <a:t>• Se calculan indicadores ponderados: ocupación, educación, exclusión digital, vulnerabilidad y brechas.</a:t>
             </a:r>
           </a:p>
           <a:p>
@@ -4710,7 +4705,7 @@
               </a:spcAft>
             </a:pPr>
             <a:r>
-              <a:t>• Usa inteligencia artificial para agrupar perfiles y estimar quiénes tienen mayor riesgo de exclusión digital alta.</a:t>
+              <a:t>• En la plataforma se consulta el baseline, se comparan ciudades y se simulan escenarios what-if (conectividad, educación y empleo formal).</a:t>
             </a:r>
             <a:endParaRPr dirty="0">
               <a:solidFill>
@@ -4720,21 +4715,35 @@
           </a:p>
           <a:p>
             <a:r>
-              <a:t>• Permite mover tres "palancas" de política: internet en hogares de menores ingresos, educación universitaria y empleo formal.</a:t>
-            </a:r>
-          </a:p>
-          <a:p>
-            <a:r>
-              <a:t>• Compara tres escenarios ficticios (conectividad, educación e integrado) sobre el mismo punto de partida oficial.</a:t>
-            </a:r>
-          </a:p>
-          <a:p>
-            <a:r>
-              <a:t>• Todo se consulta en una plataforma abierta: eph-analyzer.streamlit.app/GEMEPH</a:t>
-            </a:r>
-          </a:p>
-        </p:txBody>
-      </p:sp>
+              <a:t>• Resultado: una herramienta abierta del Observatorio de IA para investigación, docencia y decisión.</a:t>
+            </a:r>
+          </a:p>
+        </p:txBody>
+      </p:sp>
+      <p:pic>
+        <p:nvPicPr>
+          <p:cNvPr id="11" name="Picture 10" descr="gemeph_sistema.png"/>
+          <p:cNvPicPr>
+            <a:picLocks noChangeAspect="1"/>
+          </p:cNvPicPr>
+          <p:nvPr/>
+        </p:nvPicPr>
+        <p:blipFill>
+          <a:blip r:embed="rId3"/>
+          <a:stretch>
+            <a:fillRect/>
+          </a:stretch>
+        </p:blipFill>
+        <p:spPr>
+          <a:xfrm>
+            <a:off x="5989320" y="1965960"/>
+            <a:ext cx="5760720" cy="3703320"/>
+          </a:xfrm>
+          <a:prstGeom prst="rect">
+            <a:avLst/>
+          </a:prstGeom>
+        </p:spPr>
+      </p:pic>
     </p:spTree>
   </p:cSld>
   <p:clrMapOvr>

</xml_diff>